<commit_message>
refactor: decouple layout generation from title handling and add fallback content for empty slide columns
</commit_message>
<xml_diff>
--- a/templates/presentation_template_en.pptx
+++ b/templates/presentation_template_en.pptx
@@ -32,7 +32,7 @@
       <p:boldItalic r:id="rId18"/>
     </p:embeddedFont>
     <p:embeddedFont>
-      <p:font typeface="Sora" pitchFamily="2" charset="0"/>
+      <p:font typeface="Sora"/>
       <p:regular r:id="rId19"/>
       <p:bold r:id="rId20"/>
     </p:embeddedFont>
@@ -1143,7 +1143,7 @@
         </p:nvSpPr>
         <p:spPr>
           <a:xfrm>
-            <a:off x="381300" y="685800"/>
+            <a:off x="381000" y="685800"/>
             <a:ext cx="6096000" cy="3429000"/>
           </a:xfrm>
           <a:custGeom>
@@ -1753,7 +1753,7 @@
         </p:nvSpPr>
         <p:spPr>
           <a:xfrm>
-            <a:off x="381300" y="685800"/>
+            <a:off x="381000" y="685800"/>
             <a:ext cx="6096000" cy="3429000"/>
           </a:xfrm>
           <a:custGeom>
@@ -1997,7 +1997,7 @@
         </p:nvSpPr>
         <p:spPr>
           <a:xfrm>
-            <a:off x="381300" y="685800"/>
+            <a:off x="381000" y="685800"/>
             <a:ext cx="6096000" cy="3429000"/>
           </a:xfrm>
           <a:custGeom>
@@ -2241,7 +2241,7 @@
         </p:nvSpPr>
         <p:spPr>
           <a:xfrm>
-            <a:off x="381300" y="685800"/>
+            <a:off x="381000" y="685800"/>
             <a:ext cx="6096000" cy="3429000"/>
           </a:xfrm>
           <a:custGeom>
@@ -4290,6 +4290,13 @@
             <a:noFill/>
           </a:ln>
         </p:spPr>
+        <p:txBody>
+          <a:bodyPr/>
+          <a:lstStyle/>
+          <a:p>
+            <a:endParaRPr lang="en-US"/>
+          </a:p>
+        </p:txBody>
       </p:sp>
     </p:spTree>
   </p:cSld>
@@ -10752,7 +10759,7 @@
               <a:buSzPct val="111111"/>
               <a:buNone/>
             </a:pPr>
-            <a:endParaRPr/>
+            <a:endParaRPr dirty="0"/>
           </a:p>
         </p:txBody>
       </p:sp>
@@ -10844,7 +10851,7 @@
               <a:buSzPts val="1800"/>
               <a:buNone/>
             </a:pPr>
-            <a:endParaRPr/>
+            <a:endParaRPr dirty="0"/>
           </a:p>
         </p:txBody>
       </p:sp>
@@ -12463,7 +12470,7 @@
               <a:buSzPct val="111111"/>
               <a:buNone/>
             </a:pPr>
-            <a:endParaRPr/>
+            <a:endParaRPr dirty="0"/>
           </a:p>
         </p:txBody>
       </p:sp>
@@ -12509,7 +12516,7 @@
               <a:buSzPts val="1800"/>
               <a:buNone/>
             </a:pPr>
-            <a:endParaRPr/>
+            <a:endParaRPr dirty="0"/>
           </a:p>
         </p:txBody>
       </p:sp>
@@ -12555,7 +12562,7 @@
               <a:buSzPts val="1800"/>
               <a:buNone/>
             </a:pPr>
-            <a:endParaRPr/>
+            <a:endParaRPr dirty="0"/>
           </a:p>
         </p:txBody>
       </p:sp>
@@ -12693,7 +12700,7 @@
               <a:buNone/>
             </a:pPr>
             <a:r>
-              <a:rPr lang="en-GB" sz="8000" b="0" i="0" u="none" strike="noStrike" cap="none">
+              <a:rPr lang="en-GB" sz="8000" b="0" i="0" u="none" strike="noStrike" cap="none" dirty="0">
                 <a:solidFill>
                   <a:srgbClr val="153988"/>
                 </a:solidFill>
@@ -12705,7 +12712,7 @@
               <a:t>02</a:t>
             </a:r>
             <a:br>
-              <a:rPr lang="en-GB" sz="4000" b="0" i="0" u="none" strike="noStrike" cap="none">
+              <a:rPr lang="en-GB" sz="4000" b="0" i="0" u="none" strike="noStrike" cap="none" dirty="0">
                 <a:solidFill>
                   <a:srgbClr val="153988"/>
                 </a:solidFill>
@@ -12716,7 +12723,7 @@
               </a:rPr>
             </a:br>
             <a:r>
-              <a:rPr lang="en-GB" sz="4000" b="0" i="0" u="none" strike="noStrike" cap="none">
+              <a:rPr lang="en-GB" sz="4000" b="0" i="0" u="none" strike="noStrike" cap="none" dirty="0">
                 <a:solidFill>
                   <a:srgbClr val="153988"/>
                 </a:solidFill>
@@ -12727,7 +12734,7 @@
               </a:rPr>
               <a:t>Skills &amp; Education</a:t>
             </a:r>
-            <a:endParaRPr sz="4000" b="0" i="0" u="none" strike="noStrike" cap="none">
+            <a:endParaRPr sz="4000" b="0" i="0" u="none" strike="noStrike" cap="none" dirty="0">
               <a:solidFill>
                 <a:srgbClr val="153988"/>
               </a:solidFill>
@@ -12755,7 +12762,7 @@
               <a:buFont typeface="Arial"/>
               <a:buNone/>
             </a:pPr>
-            <a:endParaRPr sz="3000" b="0" i="0" u="none" strike="noStrike" cap="none">
+            <a:endParaRPr sz="3000" b="0" i="0" u="none" strike="noStrike" cap="none" dirty="0">
               <a:solidFill>
                 <a:srgbClr val="153988"/>
               </a:solidFill>
@@ -12784,7 +12791,7 @@
               <a:buNone/>
             </a:pPr>
             <a:r>
-              <a:rPr lang="en-GB" sz="1800" b="0" i="0" u="none" strike="noStrike" cap="none">
+              <a:rPr lang="en-GB" sz="1800" b="0" i="0" u="none" strike="noStrike" cap="none" dirty="0">
                 <a:solidFill>
                   <a:srgbClr val="153988"/>
                 </a:solidFill>
@@ -12795,7 +12802,7 @@
               </a:rPr>
               <a:t>What skills, education, and/or training are required for the role(s) you’ve found? What attributes will you need to acquire to apply for the opportunity identified in Part 1 (Opportunities)?</a:t>
             </a:r>
-            <a:endParaRPr sz="1800" b="0" i="0" u="none" strike="noStrike" cap="none">
+            <a:endParaRPr sz="1800" b="0" i="0" u="none" strike="noStrike" cap="none" dirty="0">
               <a:solidFill>
                 <a:srgbClr val="153988"/>
               </a:solidFill>
@@ -12940,7 +12947,7 @@
               <a:buSzPct val="111111"/>
               <a:buNone/>
             </a:pPr>
-            <a:endParaRPr/>
+            <a:endParaRPr dirty="0"/>
           </a:p>
         </p:txBody>
       </p:sp>
@@ -12986,7 +12993,7 @@
               <a:buSzPts val="1800"/>
               <a:buNone/>
             </a:pPr>
-            <a:endParaRPr/>
+            <a:endParaRPr dirty="0"/>
           </a:p>
         </p:txBody>
       </p:sp>
@@ -13032,7 +13039,7 @@
               <a:buSzPts val="1800"/>
               <a:buNone/>
             </a:pPr>
-            <a:endParaRPr/>
+            <a:endParaRPr dirty="0"/>
           </a:p>
         </p:txBody>
       </p:sp>
@@ -13417,7 +13424,7 @@
               <a:buSzPct val="111111"/>
               <a:buNone/>
             </a:pPr>
-            <a:endParaRPr/>
+            <a:endParaRPr dirty="0"/>
           </a:p>
         </p:txBody>
       </p:sp>
@@ -13463,7 +13470,7 @@
               <a:buSzPts val="1800"/>
               <a:buNone/>
             </a:pPr>
-            <a:endParaRPr/>
+            <a:endParaRPr dirty="0"/>
           </a:p>
         </p:txBody>
       </p:sp>
@@ -13509,7 +13516,7 @@
               <a:buSzPts val="1800"/>
               <a:buNone/>
             </a:pPr>
-            <a:endParaRPr/>
+            <a:endParaRPr dirty="0"/>
           </a:p>
         </p:txBody>
       </p:sp>

</xml_diff>